<commit_message>
docs: update 4-slide PPT with Team EPIX details, approach, key features, and challenges overcome
</commit_message>
<xml_diff>
--- a/Crisis_Command_Presentation.pptx
+++ b/Crisis_Command_Presentation.pptx
@@ -3107,8 +3107,8 @@
         </p:nvSpPr>
         <p:spPr>
           <a:xfrm>
-            <a:off x="731520" y="914400"/>
-            <a:ext cx="3291840" cy="365760"/>
+            <a:off x="731520" y="594360"/>
+            <a:ext cx="2926080" cy="347472"/>
           </a:xfrm>
           <a:prstGeom prst="roundRect">
             <a:avLst/>
@@ -3161,8 +3161,8 @@
         </p:nvSpPr>
         <p:spPr>
           <a:xfrm>
-            <a:off x="731520" y="1371600"/>
-            <a:ext cx="10698480" cy="1645920"/>
+            <a:off x="731520" y="1005840"/>
+            <a:ext cx="10698480" cy="1280160"/>
           </a:xfrm>
           <a:prstGeom prst="rect">
             <a:avLst/>
@@ -3176,30 +3176,30 @@
           <a:lstStyle/>
           <a:p>
             <a:pPr>
-              <a:defRPr sz="3600" b="1">
+              <a:defRPr sz="2800" b="1">
                 <a:solidFill>
                   <a:srgbClr val="F8FAFC"/>
                 </a:solidFill>
               </a:defRPr>
             </a:pPr>
             <a:r>
-              <a:t>Multi-Agent Emergency Response &amp;</a:t>
+              <a:t>The Multi-Agent Emergency Response &amp;</a:t>
             </a:r>
             <a:br/>
             <a:r>
-              <a:t>Autonomous Resource Coordination</a:t>
-            </a:r>
-          </a:p>
-          <a:p>
-            <a:pPr>
-              <a:defRPr sz="1500">
+              <a:t>Resource Coordination Agent</a:t>
+            </a:r>
+          </a:p>
+          <a:p>
+            <a:pPr>
+              <a:defRPr sz="1300">
                 <a:solidFill>
                   <a:srgbClr val="0EA5E9"/>
                 </a:solidFill>
               </a:defRPr>
             </a:pPr>
             <a:r>
-              <a:t>Next-Generation LangGraph StateGraph Architecture with Deterministic Triage &amp; Dynamic Replanning</a:t>
+              <a:t>Problem Statement: Autonomous cross-agency coordination, deterministic prioritization &amp; dynamic replanning for simultaneous catastrophic disasters.</a:t>
             </a:r>
           </a:p>
         </p:txBody>
@@ -3212,14 +3212,180 @@
         </p:nvSpPr>
         <p:spPr>
           <a:xfrm>
-            <a:off x="731520" y="3291840"/>
-            <a:ext cx="3383280" cy="2926080"/>
+            <a:off x="731520" y="2468880"/>
+            <a:ext cx="5486400" cy="3931920"/>
           </a:xfrm>
           <a:prstGeom prst="roundRect">
             <a:avLst/>
           </a:prstGeom>
           <a:solidFill>
-            <a:srgbClr val="111827"/>
+            <a:srgbClr val="0F172A"/>
+          </a:solidFill>
+          <a:ln>
+            <a:solidFill>
+              <a:srgbClr val="0EA5E9"/>
+            </a:solidFill>
+          </a:ln>
+        </p:spPr>
+        <p:style>
+          <a:lnRef idx="1">
+            <a:schemeClr val="accent1"/>
+          </a:lnRef>
+          <a:fillRef idx="3">
+            <a:schemeClr val="accent1"/>
+          </a:fillRef>
+          <a:effectRef idx="2">
+            <a:schemeClr val="accent1"/>
+          </a:effectRef>
+          <a:fontRef idx="minor">
+            <a:schemeClr val="lt1"/>
+          </a:fontRef>
+        </p:style>
+        <p:txBody>
+          <a:bodyPr rtlCol="0" anchor="ctr" wrap="square" lIns="228600" rIns="228600" tIns="228600"/>
+          <a:lstStyle/>
+          <a:p>
+            <a:pPr algn="ctr">
+              <a:defRPr sz="1100" b="1">
+                <a:solidFill>
+                  <a:srgbClr val="0EA5E9"/>
+                </a:solidFill>
+              </a:defRPr>
+            </a:pPr>
+            <a:r>
+              <a:t>TEAM PROFILE // EPIX</a:t>
+            </a:r>
+          </a:p>
+          <a:p>
+            <a:pPr>
+              <a:defRPr sz="1600" b="1">
+                <a:solidFill>
+                  <a:srgbClr val="F8FAFC"/>
+                </a:solidFill>
+              </a:defRPr>
+            </a:pPr>
+            <a:r>
+              <a:t>Team Members &amp; Specializations</a:t>
+            </a:r>
+          </a:p>
+          <a:p/>
+          <a:p>
+            <a:pPr>
+              <a:defRPr sz="1200" b="1">
+                <a:solidFill>
+                  <a:srgbClr val="38BDF8"/>
+                </a:solidFill>
+              </a:defRPr>
+            </a:pPr>
+            <a:r>
+              <a:t>• DIVYANSHU YADAV [25MCA00PY0036] — Team Leader</a:t>
+            </a:r>
+          </a:p>
+          <a:p>
+            <a:pPr>
+              <a:defRPr sz="1000">
+                <a:solidFill>
+                  <a:srgbClr val="94A3B8"/>
+                </a:solidFill>
+              </a:defRPr>
+            </a:pPr>
+            <a:r>
+              <a:t>  LangGraph architecture, orchestration, dynamic replanning engine.</a:t>
+            </a:r>
+          </a:p>
+          <a:p/>
+          <a:p>
+            <a:pPr>
+              <a:defRPr sz="1200" b="1">
+                <a:solidFill>
+                  <a:srgbClr val="38BDF8"/>
+                </a:solidFill>
+              </a:defRPr>
+            </a:pPr>
+            <a:r>
+              <a:t>• SANDEEP KUMAR [25MCA00PY0037] — Research &amp; Documentation</a:t>
+            </a:r>
+          </a:p>
+          <a:p>
+            <a:pPr>
+              <a:defRPr sz="1000">
+                <a:solidFill>
+                  <a:srgbClr val="94A3B8"/>
+                </a:solidFill>
+              </a:defRPr>
+            </a:pPr>
+            <a:r>
+              <a:t>  FEMA NIMS ICS-201 alignment, multi-hazard disaster threat modeling.</a:t>
+            </a:r>
+          </a:p>
+          <a:p/>
+          <a:p>
+            <a:pPr>
+              <a:defRPr sz="1200" b="1">
+                <a:solidFill>
+                  <a:srgbClr val="38BDF8"/>
+                </a:solidFill>
+              </a:defRPr>
+            </a:pPr>
+            <a:r>
+              <a:t>• SUGANYA S [25MCA00PY0016] — Backend Engineering</a:t>
+            </a:r>
+          </a:p>
+          <a:p>
+            <a:pPr>
+              <a:defRPr sz="1000">
+                <a:solidFill>
+                  <a:srgbClr val="94A3B8"/>
+                </a:solidFill>
+              </a:defRPr>
+            </a:pPr>
+            <a:r>
+              <a:t>  FastAPI async services, deterministic priority math, REST APIs &amp; Docker.</a:t>
+            </a:r>
+          </a:p>
+          <a:p/>
+          <a:p>
+            <a:pPr>
+              <a:defRPr sz="1200" b="1">
+                <a:solidFill>
+                  <a:srgbClr val="38BDF8"/>
+                </a:solidFill>
+              </a:defRPr>
+            </a:pPr>
+            <a:r>
+              <a:t>• VIKRAM KUMAR MODI [26MCA00PY0016] — Frontend &amp; 3D UI</a:t>
+            </a:r>
+          </a:p>
+          <a:p>
+            <a:pPr>
+              <a:defRPr sz="1000">
+                <a:solidFill>
+                  <a:srgbClr val="94A3B8"/>
+                </a:solidFill>
+              </a:defRPr>
+            </a:pPr>
+            <a:r>
+              <a:t>  Three.js WebGL globe, Leaflet GIS vectors, audio dispatch &amp; radio console.</a:t>
+            </a:r>
+          </a:p>
+        </p:txBody>
+      </p:sp>
+      <p:sp>
+        <p:nvSpPr>
+          <p:cNvPr id="5" name="Rounded Rectangle 4"/>
+          <p:cNvSpPr/>
+          <p:nvPr/>
+        </p:nvSpPr>
+        <p:spPr>
+          <a:xfrm>
+            <a:off x="6492240" y="2468880"/>
+            <a:ext cx="4937760" cy="3931920"/>
+          </a:xfrm>
+          <a:prstGeom prst="roundRect">
+            <a:avLst/>
+          </a:prstGeom>
+          <a:solidFill>
+            <a:srgbClr val="0F172A"/>
           </a:solidFill>
           <a:ln>
             <a:solidFill>
@@ -3246,14 +3412,14 @@
           <a:lstStyle/>
           <a:p>
             <a:pPr algn="ctr">
-              <a:defRPr sz="1000" b="1">
+              <a:defRPr sz="1100" b="1">
                 <a:solidFill>
                   <a:srgbClr val="EF4444"/>
                 </a:solidFill>
               </a:defRPr>
             </a:pPr>
             <a:r>
-              <a:t>THE CORE PROBLEM</a:t>
+              <a:t>EXECUTIVE MISSION &amp; SCOPE</a:t>
             </a:r>
           </a:p>
           <a:p>
@@ -3265,250 +3431,107 @@
               </a:defRPr>
             </a:pPr>
             <a:r>
-              <a:t>Disaster Grid Overload</a:t>
+              <a:t>Autonomous Disaster Grid</a:t>
             </a:r>
           </a:p>
           <a:p/>
           <a:p>
             <a:pPr>
-              <a:defRPr sz="1200">
+              <a:defRPr sz="1200" b="1">
+                <a:solidFill>
+                  <a:srgbClr val="F87171"/>
+                </a:solidFill>
+              </a:defRPr>
+            </a:pPr>
+            <a:r>
+              <a:t>✔ Multi-Incident Situational Triage</a:t>
+            </a:r>
+          </a:p>
+          <a:p>
+            <a:pPr>
+              <a:defRPr sz="1000">
                 <a:solidFill>
                   <a:srgbClr val="CBD5E1"/>
                 </a:solidFill>
               </a:defRPr>
             </a:pPr>
             <a:r>
-              <a:t>• Simultaneous multi-hazard emergencies overwhelm human dispatch centers.</a:t>
-            </a:r>
-          </a:p>
-          <a:p>
-            <a:pPr>
-              <a:defRPr sz="1200">
+              <a:t>   Real-time assessment of concurrent simultaneous crises (Collapses, Fires, Floods, Chemical Disasters) without cognitive lag.</a:t>
+            </a:r>
+          </a:p>
+          <a:p/>
+          <a:p>
+            <a:pPr>
+              <a:defRPr sz="1200" b="1">
+                <a:solidFill>
+                  <a:srgbClr val="F87171"/>
+                </a:solidFill>
+              </a:defRPr>
+            </a:pPr>
+            <a:r>
+              <a:t>✔ Deterministic Cross-Agency Dispatch</a:t>
+            </a:r>
+          </a:p>
+          <a:p>
+            <a:pPr>
+              <a:defRPr sz="1000">
                 <a:solidFill>
                   <a:srgbClr val="CBD5E1"/>
                 </a:solidFill>
               </a:defRPr>
             </a:pPr>
             <a:r>
-              <a:t>• Inter-agency coordination silos delay medical, fire, and rescue mobilization.</a:t>
-            </a:r>
-          </a:p>
-          <a:p>
-            <a:pPr>
-              <a:defRPr sz="1200">
+              <a:t>   Autonomous coordination of limited ambulances, fire trucks, rescue teams, and police units based on verifiable life-safety scores.</a:t>
+            </a:r>
+          </a:p>
+          <a:p/>
+          <a:p>
+            <a:pPr>
+              <a:defRPr sz="1200" b="1">
+                <a:solidFill>
+                  <a:srgbClr val="F87171"/>
+                </a:solidFill>
+              </a:defRPr>
+            </a:pPr>
+            <a:r>
+              <a:t>✔ Adaptive Replanning On-The-Fly</a:t>
+            </a:r>
+          </a:p>
+          <a:p>
+            <a:pPr>
+              <a:defRPr sz="1000">
                 <a:solidFill>
                   <a:srgbClr val="CBD5E1"/>
                 </a:solidFill>
               </a:defRPr>
             </a:pPr>
             <a:r>
-              <a:t>• Resource failures trigger chaotic, uncoordinated manual reallocation.</a:t>
-            </a:r>
-          </a:p>
-        </p:txBody>
-      </p:sp>
-      <p:sp>
-        <p:nvSpPr>
-          <p:cNvPr id="5" name="Rounded Rectangle 4"/>
-          <p:cNvSpPr/>
-          <p:nvPr/>
-        </p:nvSpPr>
-        <p:spPr>
-          <a:xfrm>
-            <a:off x="4389120" y="3291840"/>
-            <a:ext cx="3383280" cy="2926080"/>
-          </a:xfrm>
-          <a:prstGeom prst="roundRect">
-            <a:avLst/>
-          </a:prstGeom>
-          <a:solidFill>
-            <a:srgbClr val="111827"/>
-          </a:solidFill>
-          <a:ln>
-            <a:solidFill>
-              <a:srgbClr val="0EA5E9"/>
-            </a:solidFill>
-          </a:ln>
-        </p:spPr>
-        <p:style>
-          <a:lnRef idx="1">
-            <a:schemeClr val="accent1"/>
-          </a:lnRef>
-          <a:fillRef idx="3">
-            <a:schemeClr val="accent1"/>
-          </a:fillRef>
-          <a:effectRef idx="2">
-            <a:schemeClr val="accent1"/>
-          </a:effectRef>
-          <a:fontRef idx="minor">
-            <a:schemeClr val="lt1"/>
-          </a:fontRef>
-        </p:style>
-        <p:txBody>
-          <a:bodyPr rtlCol="0" anchor="ctr" wrap="square" lIns="228600" rIns="228600" tIns="228600"/>
-          <a:lstStyle/>
-          <a:p>
-            <a:pPr algn="ctr">
-              <a:defRPr sz="1000" b="1">
-                <a:solidFill>
-                  <a:srgbClr val="0EA5E9"/>
-                </a:solidFill>
-              </a:defRPr>
-            </a:pPr>
-            <a:r>
-              <a:t>OUR SOLUTION</a:t>
-            </a:r>
-          </a:p>
-          <a:p>
-            <a:pPr>
-              <a:defRPr sz="1600" b="1">
-                <a:solidFill>
-                  <a:srgbClr val="F8FAFC"/>
-                </a:solidFill>
-              </a:defRPr>
-            </a:pPr>
-            <a:r>
-              <a:t>Agentic StateGraph Engine</a:t>
+              <a:t>   Dynamic preemption of units when critical new emergencies strike or apparatus fail, with complete human-in-the-loop oversight.</a:t>
             </a:r>
           </a:p>
           <a:p/>
           <a:p>
             <a:pPr>
-              <a:defRPr sz="1200">
+              <a:defRPr sz="1200" b="1">
+                <a:solidFill>
+                  <a:srgbClr val="F87171"/>
+                </a:solidFill>
+              </a:defRPr>
+            </a:pPr>
+            <a:r>
+              <a:t>✔ Standardized Interoperability</a:t>
+            </a:r>
+          </a:p>
+          <a:p>
+            <a:pPr>
+              <a:defRPr sz="1000">
                 <a:solidFill>
                   <a:srgbClr val="CBD5E1"/>
                 </a:solidFill>
               </a:defRPr>
             </a:pPr>
             <a:r>
-              <a:t>• Multi-agent LangGraph orchestration with sub-second assessment triage.</a:t>
-            </a:r>
-          </a:p>
-          <a:p>
-            <a:pPr>
-              <a:defRPr sz="1200">
-                <a:solidFill>
-                  <a:srgbClr val="CBD5E1"/>
-                </a:solidFill>
-              </a:defRPr>
-            </a:pPr>
-            <a:r>
-              <a:t>• Multi-factor deterministic priority scoring (Severity, Urgency, Casualties).</a:t>
-            </a:r>
-          </a:p>
-          <a:p>
-            <a:pPr>
-              <a:defRPr sz="1200">
-                <a:solidFill>
-                  <a:srgbClr val="CBD5E1"/>
-                </a:solidFill>
-              </a:defRPr>
-            </a:pPr>
-            <a:r>
-              <a:t>• Optimal greedy resource allocation with dynamic tactical preemption.</a:t>
-            </a:r>
-          </a:p>
-        </p:txBody>
-      </p:sp>
-      <p:sp>
-        <p:nvSpPr>
-          <p:cNvPr id="6" name="Rounded Rectangle 5"/>
-          <p:cNvSpPr/>
-          <p:nvPr/>
-        </p:nvSpPr>
-        <p:spPr>
-          <a:xfrm>
-            <a:off x="8046720" y="3291840"/>
-            <a:ext cx="3383280" cy="2926080"/>
-          </a:xfrm>
-          <a:prstGeom prst="roundRect">
-            <a:avLst/>
-          </a:prstGeom>
-          <a:solidFill>
-            <a:srgbClr val="111827"/>
-          </a:solidFill>
-          <a:ln>
-            <a:solidFill>
-              <a:srgbClr val="10B981"/>
-            </a:solidFill>
-          </a:ln>
-        </p:spPr>
-        <p:style>
-          <a:lnRef idx="1">
-            <a:schemeClr val="accent1"/>
-          </a:lnRef>
-          <a:fillRef idx="3">
-            <a:schemeClr val="accent1"/>
-          </a:fillRef>
-          <a:effectRef idx="2">
-            <a:schemeClr val="accent1"/>
-          </a:effectRef>
-          <a:fontRef idx="minor">
-            <a:schemeClr val="lt1"/>
-          </a:fontRef>
-        </p:style>
-        <p:txBody>
-          <a:bodyPr rtlCol="0" anchor="ctr" wrap="square" lIns="228600" rIns="228600" tIns="228600"/>
-          <a:lstStyle/>
-          <a:p>
-            <a:pPr algn="ctr">
-              <a:defRPr sz="1000" b="1">
-                <a:solidFill>
-                  <a:srgbClr val="10B981"/>
-                </a:solidFill>
-              </a:defRPr>
-            </a:pPr>
-            <a:r>
-              <a:t>HUMAN GOVERNANCE</a:t>
-            </a:r>
-          </a:p>
-          <a:p>
-            <a:pPr>
-              <a:defRPr sz="1600" b="1">
-                <a:solidFill>
-                  <a:srgbClr val="F8FAFC"/>
-                </a:solidFill>
-              </a:defRPr>
-            </a:pPr>
-            <a:r>
-              <a:t>Commander Safeguards</a:t>
-            </a:r>
-          </a:p>
-          <a:p/>
-          <a:p>
-            <a:pPr>
-              <a:defRPr sz="1200">
-                <a:solidFill>
-                  <a:srgbClr val="CBD5E1"/>
-                </a:solidFill>
-              </a:defRPr>
-            </a:pPr>
-            <a:r>
-              <a:t>• Human-in-the-Loop decision gates for critical reallocations (&gt;85 score).</a:t>
-            </a:r>
-          </a:p>
-          <a:p>
-            <a:pPr>
-              <a:defRPr sz="1200">
-                <a:solidFill>
-                  <a:srgbClr val="CBD5E1"/>
-                </a:solidFill>
-              </a:defRPr>
-            </a:pPr>
-            <a:r>
-              <a:t>• Auditable 'Before vs After' tactical shifts with FEMA ICS-201 plan export.</a:t>
-            </a:r>
-          </a:p>
-          <a:p>
-            <a:pPr>
-              <a:defRPr sz="1200">
-                <a:solidFill>
-                  <a:srgbClr val="CBD5E1"/>
-                </a:solidFill>
-              </a:defRPr>
-            </a:pPr>
-            <a:r>
-              <a:t>• Natural language AI tactical radio with Web Audio synthesized dispatch.</a:t>
+              <a:t>   Direct FEMA Form ICS-201 compliance, tactical GIS telemetry, and natural language radio command.</a:t>
             </a:r>
           </a:p>
         </p:txBody>
@@ -3547,8 +3570,8 @@
         </p:nvSpPr>
         <p:spPr>
           <a:xfrm>
-            <a:off x="731520" y="365760"/>
-            <a:ext cx="10698480" cy="320040"/>
+            <a:off x="731520" y="320040"/>
+            <a:ext cx="10698480" cy="274320"/>
           </a:xfrm>
           <a:prstGeom prst="rect">
             <a:avLst/>
@@ -3569,7 +3592,7 @@
               </a:defRPr>
             </a:pPr>
             <a:r>
-              <a:t>CORE ARCHITECTURE // MULTI-AGENT STATE MACHINE</a:t>
+              <a:t>SYSTEM DESIGN // AGENTIC ARCHITECTURE</a:t>
             </a:r>
           </a:p>
         </p:txBody>
@@ -3582,8 +3605,8 @@
         </p:nvSpPr>
         <p:spPr>
           <a:xfrm>
-            <a:off x="731520" y="640080"/>
-            <a:ext cx="10698480" cy="640080"/>
+            <a:off x="731520" y="594360"/>
+            <a:ext cx="10698480" cy="548640"/>
           </a:xfrm>
           <a:prstGeom prst="rect">
             <a:avLst/>
@@ -3597,14 +3620,14 @@
           <a:lstStyle/>
           <a:p>
             <a:pPr>
-              <a:defRPr sz="2400" b="1">
+              <a:defRPr sz="2200" b="1">
                 <a:solidFill>
                   <a:srgbClr val="F8FAFC"/>
                 </a:solidFill>
               </a:defRPr>
             </a:pPr>
             <a:r>
-              <a:t>System Architecture: LangGraph StateGraph &amp; Decision Flow</a:t>
+              <a:t>Approach &amp; Architecture: Multi-Agent LangGraph State Machine</a:t>
             </a:r>
           </a:p>
         </p:txBody>
@@ -3617,8 +3640,8 @@
         </p:nvSpPr>
         <p:spPr>
           <a:xfrm>
-            <a:off x="731520" y="1280160"/>
-            <a:ext cx="10698480" cy="18288"/>
+            <a:off x="731520" y="1188720"/>
+            <a:ext cx="10728655" cy="18288"/>
           </a:xfrm>
           <a:prstGeom prst="rect">
             <a:avLst/>
@@ -3662,14 +3685,14 @@
         </p:nvSpPr>
         <p:spPr>
           <a:xfrm>
-            <a:off x="731520" y="1554480"/>
-            <a:ext cx="5212080" cy="4846320"/>
+            <a:off x="731520" y="1463040"/>
+            <a:ext cx="3383280" cy="4937760"/>
           </a:xfrm>
           <a:prstGeom prst="roundRect">
             <a:avLst/>
           </a:prstGeom>
           <a:solidFill>
-            <a:srgbClr val="111827"/>
+            <a:srgbClr val="0F172A"/>
           </a:solidFill>
           <a:ln>
             <a:solidFill>
@@ -3692,130 +3715,134 @@
           </a:fontRef>
         </p:style>
         <p:txBody>
-          <a:bodyPr rtlCol="0" anchor="ctr" wrap="square" lIns="274320" rIns="274320" tIns="274320"/>
+          <a:bodyPr rtlCol="0" anchor="ctr" wrap="square" lIns="182880" rIns="182880" tIns="182880"/>
           <a:lstStyle/>
           <a:p>
             <a:pPr algn="ctr">
+              <a:defRPr sz="1000" b="1">
+                <a:solidFill>
+                  <a:srgbClr val="0EA5E9"/>
+                </a:solidFill>
+              </a:defRPr>
+            </a:pPr>
+            <a:r>
+              <a:t>1. MULTI-AGENT PIPELINE</a:t>
+            </a:r>
+          </a:p>
+          <a:p>
+            <a:pPr>
+              <a:defRPr sz="1500" b="1">
+                <a:solidFill>
+                  <a:srgbClr val="F8FAFC"/>
+                </a:solidFill>
+              </a:defRPr>
+            </a:pPr>
+            <a:r>
+              <a:t>Specialized LangGraph Agents</a:t>
+            </a:r>
+          </a:p>
+          <a:p/>
+          <a:p>
+            <a:pPr>
               <a:defRPr sz="1100" b="1">
                 <a:solidFill>
-                  <a:srgbClr val="0EA5E9"/>
-                </a:solidFill>
-              </a:defRPr>
-            </a:pPr>
-            <a:r>
-              <a:t>SPECIALIZED AGENT PIPELINE</a:t>
-            </a:r>
-          </a:p>
-          <a:p>
-            <a:pPr>
-              <a:defRPr sz="1800" b="1">
-                <a:solidFill>
-                  <a:srgbClr val="F8FAFC"/>
-                </a:solidFill>
-              </a:defRPr>
-            </a:pPr>
-            <a:r>
-              <a:t>LangGraph Cyclic State Machine</a:t>
+                  <a:srgbClr val="38BDF8"/>
+                </a:solidFill>
+              </a:defRPr>
+            </a:pPr>
+            <a:r>
+              <a:t>Triage &amp; Assessment Agent</a:t>
+            </a:r>
+          </a:p>
+          <a:p>
+            <a:pPr>
+              <a:defRPr sz="950">
+                <a:solidFill>
+                  <a:srgbClr val="CBD5E1"/>
+                </a:solidFill>
+              </a:defRPr>
+            </a:pPr>
+            <a:r>
+              <a:t>Ingests 911 telemetry. Evaluates Severity (1-10), Urgency (1-10), population density, and casualty risks.</a:t>
             </a:r>
           </a:p>
           <a:p/>
           <a:p>
             <a:pPr>
-              <a:defRPr sz="1300" b="1">
+              <a:defRPr sz="1100" b="1">
                 <a:solidFill>
                   <a:srgbClr val="38BDF8"/>
                 </a:solidFill>
               </a:defRPr>
             </a:pPr>
             <a:r>
-              <a:t>1. Triage &amp; Assessment Agent</a:t>
-            </a:r>
-          </a:p>
-          <a:p>
-            <a:pPr>
-              <a:defRPr sz="1100">
+              <a:t>Priority Scoring Engine</a:t>
+            </a:r>
+          </a:p>
+          <a:p>
+            <a:pPr>
+              <a:defRPr sz="950">
                 <a:solidFill>
                   <a:srgbClr val="CBD5E1"/>
                 </a:solidFill>
               </a:defRPr>
             </a:pPr>
             <a:r>
-              <a:t>Ingests 911 telemetry, evaluates severity (1-10), urgency (1-10), and potential casualties.</a:t>
+              <a:t>Mathematically computes priority score:</a:t>
+            </a:r>
+            <a:br/>
+            <a:r>
+              <a:t>Score = 0.4*Severity + 0.3*Urgency + 0.3*CasualtyRisk (Zero hallucination).</a:t>
             </a:r>
           </a:p>
           <a:p/>
           <a:p>
             <a:pPr>
-              <a:defRPr sz="1300" b="1">
+              <a:defRPr sz="1100" b="1">
                 <a:solidFill>
                   <a:srgbClr val="38BDF8"/>
                 </a:solidFill>
               </a:defRPr>
             </a:pPr>
             <a:r>
-              <a:t>2. Deterministic Priority Engine</a:t>
-            </a:r>
-          </a:p>
-          <a:p>
-            <a:pPr>
-              <a:defRPr sz="1100">
+              <a:t>Resource Allocation Agent</a:t>
+            </a:r>
+          </a:p>
+          <a:p>
+            <a:pPr>
+              <a:defRPr sz="950">
                 <a:solidFill>
                   <a:srgbClr val="CBD5E1"/>
                 </a:solidFill>
               </a:defRPr>
             </a:pPr>
             <a:r>
-              <a:t>Calculates priority score using multi-factor formula: Score = 0.4*Severity + 0.3*Urgency + 0.3*CasualtyRisk.</a:t>
+              <a:t>Coordinates across Fire, EMS, Rescue, and Police. Solves greedy constraint matching for scarce field units.</a:t>
             </a:r>
           </a:p>
           <a:p/>
           <a:p>
             <a:pPr>
-              <a:defRPr sz="1300" b="1">
+              <a:defRPr sz="1100" b="1">
                 <a:solidFill>
                   <a:srgbClr val="38BDF8"/>
                 </a:solidFill>
               </a:defRPr>
             </a:pPr>
             <a:r>
-              <a:t>3. Cross-Agency Allocation Agent</a:t>
-            </a:r>
-          </a:p>
-          <a:p>
-            <a:pPr>
-              <a:defRPr sz="1100">
+              <a:t>Incident Action Plan Agent</a:t>
+            </a:r>
+          </a:p>
+          <a:p>
+            <a:pPr>
+              <a:defRPr sz="950">
                 <a:solidFill>
                   <a:srgbClr val="CBD5E1"/>
                 </a:solidFill>
               </a:defRPr>
             </a:pPr>
             <a:r>
-              <a:t>Coordinates across Fire, EMS, Rescue, and Police. Solves greedy constraint matching for scarce units.</a:t>
-            </a:r>
-          </a:p>
-          <a:p/>
-          <a:p>
-            <a:pPr>
-              <a:defRPr sz="1300" b="1">
-                <a:solidFill>
-                  <a:srgbClr val="38BDF8"/>
-                </a:solidFill>
-              </a:defRPr>
-            </a:pPr>
-            <a:r>
-              <a:t>4. Incident Action Plan Agent</a:t>
-            </a:r>
-          </a:p>
-          <a:p>
-            <a:pPr>
-              <a:defRPr sz="1100">
-                <a:solidFill>
-                  <a:srgbClr val="CBD5E1"/>
-                </a:solidFill>
-              </a:defRPr>
-            </a:pPr>
-            <a:r>
-              <a:t>Generates structured operational briefing, assigning mission objectives and estimated response arrival.</a:t>
+              <a:t>Synthesizes operational briefings and assigns tactical operational periods.</a:t>
             </a:r>
           </a:p>
         </p:txBody>
@@ -3828,14 +3855,14 @@
         </p:nvSpPr>
         <p:spPr>
           <a:xfrm>
-            <a:off x="6217920" y="1554480"/>
-            <a:ext cx="5212080" cy="4846320"/>
+            <a:off x="4389120" y="1463040"/>
+            <a:ext cx="3383280" cy="4937760"/>
           </a:xfrm>
           <a:prstGeom prst="roundRect">
             <a:avLst/>
           </a:prstGeom>
           <a:solidFill>
-            <a:srgbClr val="111827"/>
+            <a:srgbClr val="0F172A"/>
           </a:solidFill>
           <a:ln>
             <a:solidFill>
@@ -3858,130 +3885,296 @@
           </a:fontRef>
         </p:style>
         <p:txBody>
-          <a:bodyPr rtlCol="0" anchor="ctr" wrap="square" lIns="274320" rIns="274320" tIns="274320"/>
+          <a:bodyPr rtlCol="0" anchor="ctr" wrap="square" lIns="182880" rIns="182880" tIns="182880"/>
           <a:lstStyle/>
           <a:p>
             <a:pPr algn="ctr">
+              <a:defRPr sz="1000" b="1">
+                <a:solidFill>
+                  <a:srgbClr val="EF4444"/>
+                </a:solidFill>
+              </a:defRPr>
+            </a:pPr>
+            <a:r>
+              <a:t>2. DYNAMIC REPLANNING</a:t>
+            </a:r>
+          </a:p>
+          <a:p>
+            <a:pPr>
+              <a:defRPr sz="1500" b="1">
+                <a:solidFill>
+                  <a:srgbClr val="F8FAFC"/>
+                </a:solidFill>
+              </a:defRPr>
+            </a:pPr>
+            <a:r>
+              <a:t>Adaptive State Cycles</a:t>
+            </a:r>
+          </a:p>
+          <a:p/>
+          <a:p>
+            <a:pPr>
               <a:defRPr sz="1100" b="1">
                 <a:solidFill>
-                  <a:srgbClr val="EF4444"/>
-                </a:solidFill>
-              </a:defRPr>
-            </a:pPr>
-            <a:r>
-              <a:t>DYNAMIC REPLANNING &amp; SAFETY GATES</a:t>
-            </a:r>
-          </a:p>
-          <a:p>
-            <a:pPr>
-              <a:defRPr sz="1800" b="1">
+                  <a:srgbClr val="F87171"/>
+                </a:solidFill>
+              </a:defRPr>
+            </a:pPr>
+            <a:r>
+              <a:t>Shock Event Trigger</a:t>
+            </a:r>
+          </a:p>
+          <a:p>
+            <a:pPr>
+              <a:defRPr sz="950">
+                <a:solidFill>
+                  <a:srgbClr val="CBD5E1"/>
+                </a:solidFill>
+              </a:defRPr>
+            </a:pPr>
+            <a:r>
+              <a:t>LangGraph cyclic state graph detects new critical crises or apparatus breakdowns in real time.</a:t>
+            </a:r>
+          </a:p>
+          <a:p/>
+          <a:p>
+            <a:pPr>
+              <a:defRPr sz="1100" b="1">
+                <a:solidFill>
+                  <a:srgbClr val="F87171"/>
+                </a:solidFill>
+              </a:defRPr>
+            </a:pPr>
+            <a:r>
+              <a:t>Deterministic Preemption</a:t>
+            </a:r>
+          </a:p>
+          <a:p>
+            <a:pPr>
+              <a:defRPr sz="950">
+                <a:solidFill>
+                  <a:srgbClr val="CBD5E1"/>
+                </a:solidFill>
+              </a:defRPr>
+            </a:pPr>
+            <a:r>
+              <a:t>Calculates priority delta. Automatically reassigns units from lower-priority contained incidents to save lives in critical sectors.</a:t>
+            </a:r>
+          </a:p>
+          <a:p/>
+          <a:p>
+            <a:pPr>
+              <a:defRPr sz="1100" b="1">
+                <a:solidFill>
+                  <a:srgbClr val="F87171"/>
+                </a:solidFill>
+              </a:defRPr>
+            </a:pPr>
+            <a:r>
+              <a:t>Before vs After Audit Trail</a:t>
+            </a:r>
+          </a:p>
+          <a:p>
+            <a:pPr>
+              <a:defRPr sz="950">
+                <a:solidFill>
+                  <a:srgbClr val="CBD5E1"/>
+                </a:solidFill>
+              </a:defRPr>
+            </a:pPr>
+            <a:r>
+              <a:t>Records explicit tactical justification for every preemption (e.g. Unit AMB-02 reassigned to Mass Casualty).</a:t>
+            </a:r>
+          </a:p>
+          <a:p/>
+          <a:p>
+            <a:pPr>
+              <a:defRPr sz="1100" b="1">
+                <a:solidFill>
+                  <a:srgbClr val="F87171"/>
+                </a:solidFill>
+              </a:defRPr>
+            </a:pPr>
+            <a:r>
+              <a:t>Surplus Resource Release</a:t>
+            </a:r>
+          </a:p>
+          <a:p>
+            <a:pPr>
+              <a:defRPr sz="950">
+                <a:solidFill>
+                  <a:srgbClr val="CBD5E1"/>
+                </a:solidFill>
+              </a:defRPr>
+            </a:pPr>
+            <a:r>
+              <a:t>When an incident resolves, freed units are instantly returned to available reserve pools.</a:t>
+            </a:r>
+          </a:p>
+        </p:txBody>
+      </p:sp>
+      <p:sp>
+        <p:nvSpPr>
+          <p:cNvPr id="7" name="Rounded Rectangle 6"/>
+          <p:cNvSpPr/>
+          <p:nvPr/>
+        </p:nvSpPr>
+        <p:spPr>
+          <a:xfrm>
+            <a:off x="8046720" y="1463040"/>
+            <a:ext cx="3383280" cy="4937760"/>
+          </a:xfrm>
+          <a:prstGeom prst="roundRect">
+            <a:avLst/>
+          </a:prstGeom>
+          <a:solidFill>
+            <a:srgbClr val="0F172A"/>
+          </a:solidFill>
+          <a:ln>
+            <a:solidFill>
+              <a:srgbClr val="10B981"/>
+            </a:solidFill>
+          </a:ln>
+        </p:spPr>
+        <p:style>
+          <a:lnRef idx="1">
+            <a:schemeClr val="accent1"/>
+          </a:lnRef>
+          <a:fillRef idx="3">
+            <a:schemeClr val="accent1"/>
+          </a:fillRef>
+          <a:effectRef idx="2">
+            <a:schemeClr val="accent1"/>
+          </a:effectRef>
+          <a:fontRef idx="minor">
+            <a:schemeClr val="lt1"/>
+          </a:fontRef>
+        </p:style>
+        <p:txBody>
+          <a:bodyPr rtlCol="0" anchor="ctr" wrap="square" lIns="182880" rIns="182880" tIns="182880"/>
+          <a:lstStyle/>
+          <a:p>
+            <a:pPr algn="ctr">
+              <a:defRPr sz="1000" b="1">
+                <a:solidFill>
+                  <a:srgbClr val="10B981"/>
+                </a:solidFill>
+              </a:defRPr>
+            </a:pPr>
+            <a:r>
+              <a:t>3. HUMAN GOVERNANCE</a:t>
+            </a:r>
+          </a:p>
+          <a:p>
+            <a:pPr>
+              <a:defRPr sz="1500" b="1">
                 <a:solidFill>
                   <a:srgbClr val="F8FAFC"/>
                 </a:solidFill>
               </a:defRPr>
             </a:pPr>
             <a:r>
-              <a:t>Tactical Preemption &amp; Governance</a:t>
+              <a:t>Commander Safeguards</a:t>
             </a:r>
           </a:p>
           <a:p/>
           <a:p>
             <a:pPr>
-              <a:defRPr sz="1300" b="1">
-                <a:solidFill>
-                  <a:srgbClr val="F87171"/>
-                </a:solidFill>
-              </a:defRPr>
-            </a:pPr>
-            <a:r>
-              <a:t>⚡ Sudden Shock Injection</a:t>
-            </a:r>
-          </a:p>
-          <a:p>
-            <a:pPr>
-              <a:defRPr sz="1100">
+              <a:defRPr sz="1100" b="1">
+                <a:solidFill>
+                  <a:srgbClr val="34D399"/>
+                </a:solidFill>
+              </a:defRPr>
+            </a:pPr>
+            <a:r>
+              <a:t>Human Approval Gate</a:t>
+            </a:r>
+          </a:p>
+          <a:p>
+            <a:pPr>
+              <a:defRPr sz="950">
                 <a:solidFill>
                   <a:srgbClr val="CBD5E1"/>
                 </a:solidFill>
               </a:defRPr>
             </a:pPr>
             <a:r>
-              <a:t>Triggered by incoming catastrophic disasters (e.g. Chemical Explosion) or apparatus mechanical failures.</a:t>
+              <a:t>Autonomous execution pauses whenever preemption impacts high-casualty sectors (Score &gt; 85.0).</a:t>
             </a:r>
           </a:p>
           <a:p/>
           <a:p>
             <a:pPr>
-              <a:defRPr sz="1300" b="1">
-                <a:solidFill>
-                  <a:srgbClr val="F87171"/>
-                </a:solidFill>
-              </a:defRPr>
-            </a:pPr>
-            <a:r>
-              <a:t>🔄 Priority-Driven Preemption</a:t>
-            </a:r>
-          </a:p>
-          <a:p>
-            <a:pPr>
-              <a:defRPr sz="1100">
+              <a:defRPr sz="1100" b="1">
+                <a:solidFill>
+                  <a:srgbClr val="34D399"/>
+                </a:solidFill>
+              </a:defRPr>
+            </a:pPr>
+            <a:r>
+              <a:t>Instant Visual Controls</a:t>
+            </a:r>
+          </a:p>
+          <a:p>
+            <a:pPr>
+              <a:defRPr sz="950">
                 <a:solidFill>
                   <a:srgbClr val="CBD5E1"/>
                 </a:solidFill>
               </a:defRPr>
             </a:pPr>
             <a:r>
-              <a:t>Automatically preempts units from lower-priority contained incidents and redirects them to save critical lives.</a:t>
+              <a:t>Commander receives high-visibility Replanning Banner with Approve, Reject, or Review actions.</a:t>
             </a:r>
           </a:p>
           <a:p/>
           <a:p>
             <a:pPr>
-              <a:defRPr sz="1300" b="1">
-                <a:solidFill>
-                  <a:srgbClr val="F87171"/>
-                </a:solidFill>
-              </a:defRPr>
-            </a:pPr>
-            <a:r>
-              <a:t>🛡️ Human Approval Gate</a:t>
-            </a:r>
-          </a:p>
-          <a:p>
-            <a:pPr>
-              <a:defRPr sz="1100">
+              <a:defRPr sz="1100" b="1">
+                <a:solidFill>
+                  <a:srgbClr val="34D399"/>
+                </a:solidFill>
+              </a:defRPr>
+            </a:pPr>
+            <a:r>
+              <a:t>Deterministic Fallback</a:t>
+            </a:r>
+          </a:p>
+          <a:p>
+            <a:pPr>
+              <a:defRPr sz="950">
                 <a:solidFill>
                   <a:srgbClr val="CBD5E1"/>
                 </a:solidFill>
               </a:defRPr>
             </a:pPr>
             <a:r>
-              <a:t>If preemptions affect high-casualty sectors, the system halts autonomous commit and alerts the Commander.</a:t>
+              <a:t>If external LLM APIs fail or lose connectivity, the deterministic mathematical core runs uninterrupted.</a:t>
             </a:r>
           </a:p>
           <a:p/>
           <a:p>
             <a:pPr>
-              <a:defRPr sz="1300" b="1">
-                <a:solidFill>
-                  <a:srgbClr val="F87171"/>
-                </a:solidFill>
-              </a:defRPr>
-            </a:pPr>
-            <a:r>
-              <a:t>📝 Explainable Audit Trail</a:t>
-            </a:r>
-          </a:p>
-          <a:p>
-            <a:pPr>
-              <a:defRPr sz="1100">
+              <a:defRPr sz="1100" b="1">
+                <a:solidFill>
+                  <a:srgbClr val="34D399"/>
+                </a:solidFill>
+              </a:defRPr>
+            </a:pPr>
+            <a:r>
+              <a:t>FEMA ICS-201 Alignment</a:t>
+            </a:r>
+          </a:p>
+          <a:p>
+            <a:pPr>
+              <a:defRPr sz="950">
                 <a:solidFill>
                   <a:srgbClr val="CBD5E1"/>
                 </a:solidFill>
               </a:defRPr>
             </a:pPr>
             <a:r>
-              <a:t>Displays instant 'Before vs After' differences explaining exactly WHY each resource was redirected.</a:t>
+              <a:t>Adheres to National Incident Management System (NIMS) operational reporting guidelines.</a:t>
             </a:r>
           </a:p>
         </p:txBody>
@@ -4020,8 +4213,8 @@
         </p:nvSpPr>
         <p:spPr>
           <a:xfrm>
-            <a:off x="731520" y="365760"/>
-            <a:ext cx="10698480" cy="320040"/>
+            <a:off x="731520" y="320040"/>
+            <a:ext cx="10698480" cy="274320"/>
           </a:xfrm>
           <a:prstGeom prst="rect">
             <a:avLst/>
@@ -4042,7 +4235,7 @@
               </a:defRPr>
             </a:pPr>
             <a:r>
-              <a:t>OPERATIONAL CAPABILITIES // LIVE DEMO HIGHLIGHTS</a:t>
+              <a:t>PLATFORM CAPABILITIES // LIVE DEMO HIGHLIGHTS</a:t>
             </a:r>
           </a:p>
         </p:txBody>
@@ -4055,8 +4248,8 @@
         </p:nvSpPr>
         <p:spPr>
           <a:xfrm>
-            <a:off x="731520" y="640080"/>
-            <a:ext cx="10698480" cy="640080"/>
+            <a:off x="731520" y="594360"/>
+            <a:ext cx="10698480" cy="548640"/>
           </a:xfrm>
           <a:prstGeom prst="rect">
             <a:avLst/>
@@ -4070,14 +4263,14 @@
           <a:lstStyle/>
           <a:p>
             <a:pPr>
-              <a:defRPr sz="2400" b="1">
+              <a:defRPr sz="2200" b="1">
                 <a:solidFill>
                   <a:srgbClr val="F8FAFC"/>
                 </a:solidFill>
               </a:defRPr>
             </a:pPr>
             <a:r>
-              <a:t>Key Innovations &amp; Command Center Experience</a:t>
+              <a:t>Key Functionalities &amp; Immersive Command Experience</a:t>
             </a:r>
           </a:p>
         </p:txBody>
@@ -4090,8 +4283,8 @@
         </p:nvSpPr>
         <p:spPr>
           <a:xfrm>
-            <a:off x="731520" y="1280160"/>
-            <a:ext cx="10698480" cy="18288"/>
+            <a:off x="731520" y="1188720"/>
+            <a:ext cx="10728655" cy="18288"/>
           </a:xfrm>
           <a:prstGeom prst="rect">
             <a:avLst/>
@@ -4135,14 +4328,14 @@
         </p:nvSpPr>
         <p:spPr>
           <a:xfrm>
-            <a:off x="731520" y="1554480"/>
+            <a:off x="731520" y="1463040"/>
             <a:ext cx="5212080" cy="2331720"/>
           </a:xfrm>
           <a:prstGeom prst="roundRect">
             <a:avLst/>
           </a:prstGeom>
           <a:solidFill>
-            <a:srgbClr val="111827"/>
+            <a:srgbClr val="0F172A"/>
           </a:solidFill>
           <a:ln>
             <a:solidFill>
@@ -4176,31 +4369,56 @@
               </a:defRPr>
             </a:pPr>
             <a:r>
-              <a:t>IMMERSIVE SPATIAL COMMAND</a:t>
-            </a:r>
-          </a:p>
-          <a:p>
-            <a:pPr>
-              <a:defRPr sz="1500" b="1">
+              <a:t>SPATIAL COMMAND &amp; BIOMETRICS</a:t>
+            </a:r>
+          </a:p>
+          <a:p>
+            <a:pPr>
+              <a:defRPr sz="1400" b="1">
                 <a:solidFill>
                   <a:srgbClr val="F8FAFC"/>
                 </a:solidFill>
               </a:defRPr>
             </a:pPr>
             <a:r>
-              <a:t>3D WebGL Globe &amp; Cinematic Warp</a:t>
-            </a:r>
-          </a:p>
-          <a:p>
-            <a:pPr>
-              <a:defRPr sz="1100">
+              <a:t>3D WebGL Globe &amp; Cinematic Warp Entry</a:t>
+            </a:r>
+          </a:p>
+          <a:p/>
+          <a:p>
+            <a:pPr>
+              <a:defRPr sz="1000">
                 <a:solidFill>
                   <a:srgbClr val="CBD5E1"/>
                 </a:solidFill>
               </a:defRPr>
             </a:pPr>
             <a:r>
-              <a:t>Built with Three.js. Provides a global spatial perspective before and after authentication. Features zero-password instant ID login with a cinematic camera dive warp effect into the tactical grid.</a:t>
+              <a:t>• Continuous 3D spatial particle globe built with Three.js rendering active disaster coordinates.</a:t>
+            </a:r>
+          </a:p>
+          <a:p>
+            <a:pPr>
+              <a:defRPr sz="1000">
+                <a:solidFill>
+                  <a:srgbClr val="CBD5E1"/>
+                </a:solidFill>
+              </a:defRPr>
+            </a:pPr>
+            <a:r>
+              <a:t>• Single-ID instant login (CMD-101, FIRE-01, MED-01) with zero password friction.</a:t>
+            </a:r>
+          </a:p>
+          <a:p>
+            <a:pPr>
+              <a:defRPr sz="1000">
+                <a:solidFill>
+                  <a:srgbClr val="CBD5E1"/>
+                </a:solidFill>
+              </a:defRPr>
+            </a:pPr>
+            <a:r>
+              <a:t>• Cinematic 3D camera warp transition diving through the defense grid upon authentication.</a:t>
             </a:r>
           </a:p>
         </p:txBody>
@@ -4213,14 +4431,14 @@
         </p:nvSpPr>
         <p:spPr>
           <a:xfrm>
-            <a:off x="6217920" y="1554480"/>
+            <a:off x="6217920" y="1463040"/>
             <a:ext cx="5212080" cy="2331720"/>
           </a:xfrm>
           <a:prstGeom prst="roundRect">
             <a:avLst/>
           </a:prstGeom>
           <a:solidFill>
-            <a:srgbClr val="111827"/>
+            <a:srgbClr val="0F172A"/>
           </a:solidFill>
           <a:ln>
             <a:solidFill>
@@ -4254,12 +4472,12 @@
               </a:defRPr>
             </a:pPr>
             <a:r>
-              <a:t>REAL-TIME LOGISTICS</a:t>
-            </a:r>
-          </a:p>
-          <a:p>
-            <a:pPr>
-              <a:defRPr sz="1500" b="1">
+              <a:t>REAL-TIME LOGISTICS &amp; TELEMETRY</a:t>
+            </a:r>
+          </a:p>
+          <a:p>
+            <a:pPr>
+              <a:defRPr sz="1400" b="1">
                 <a:solidFill>
                   <a:srgbClr val="F8FAFC"/>
                 </a:solidFill>
@@ -4269,16 +4487,41 @@
               <a:t>Leaflet GIS &amp; Animated Vector Corridors</a:t>
             </a:r>
           </a:p>
-          <a:p>
-            <a:pPr>
-              <a:defRPr sz="1100">
+          <a:p/>
+          <a:p>
+            <a:pPr>
+              <a:defRPr sz="1000">
                 <a:solidFill>
                   <a:srgbClr val="CBD5E1"/>
                 </a:solidFill>
               </a:defRPr>
             </a:pPr>
             <a:r>
-              <a:t>Watermark-free dark situational mapping. Dynamic dashed polylines show live apparatus trajectories with real-time geodesic distance calculations (km) and estimated time of arrival (ETA in minutes).</a:t>
+              <a:t>• Watermark-free tactical situational map utilizing Esri World Dark Gray Base &amp; OpenStreetMap.</a:t>
+            </a:r>
+          </a:p>
+          <a:p>
+            <a:pPr>
+              <a:defRPr sz="1000">
+                <a:solidFill>
+                  <a:srgbClr val="CBD5E1"/>
+                </a:solidFill>
+              </a:defRPr>
+            </a:pPr>
+            <a:r>
+              <a:t>• Dynamic animated SVG dashed polyline trajectories illustrating active apparatus dispatches.</a:t>
+            </a:r>
+          </a:p>
+          <a:p>
+            <a:pPr>
+              <a:defRPr sz="1000">
+                <a:solidFill>
+                  <a:srgbClr val="CBD5E1"/>
+                </a:solidFill>
+              </a:defRPr>
+            </a:pPr>
+            <a:r>
+              <a:t>• Real-time geodesic distance calculations (km) and Estimated Time of Arrival (ETA in minutes).</a:t>
             </a:r>
           </a:p>
         </p:txBody>
@@ -4291,14 +4534,14 @@
         </p:nvSpPr>
         <p:spPr>
           <a:xfrm>
-            <a:off x="731520" y="4114800"/>
+            <a:off x="731520" y="4023360"/>
             <a:ext cx="5212080" cy="2331720"/>
           </a:xfrm>
           <a:prstGeom prst="roundRect">
             <a:avLst/>
           </a:prstGeom>
           <a:solidFill>
-            <a:srgbClr val="111827"/>
+            <a:srgbClr val="0F172A"/>
           </a:solidFill>
           <a:ln>
             <a:solidFill>
@@ -4337,7 +4580,7 @@
           </a:p>
           <a:p>
             <a:pPr>
-              <a:defRPr sz="1500" b="1">
+              <a:defRPr sz="1400" b="1">
                 <a:solidFill>
                   <a:srgbClr val="F8FAFC"/>
                 </a:solidFill>
@@ -4347,16 +4590,41 @@
               <a:t>Natural Language AI Radio Transceiver</a:t>
             </a:r>
           </a:p>
-          <a:p>
-            <a:pPr>
-              <a:defRPr sz="1100">
+          <a:p/>
+          <a:p>
+            <a:pPr>
+              <a:defRPr sz="1000">
                 <a:solidFill>
                   <a:srgbClr val="CBD5E1"/>
                 </a:solidFill>
               </a:defRPr>
             </a:pPr>
             <a:r>
-              <a:t>Transceiver bar parses natural language speech/text orders ('Casualty update', 'Replan all sectors'). Executes agent actions with synthetic Web Audio chimes and SpeechSynthesis vocal dispatch.</a:t>
+              <a:t>• Hands-free AI radio console parsing spoken/typed orders ('Casualty status', 'Replan all sectors').</a:t>
+            </a:r>
+          </a:p>
+          <a:p>
+            <a:pPr>
+              <a:defRPr sz="1000">
+                <a:solidFill>
+                  <a:srgbClr val="CBD5E1"/>
+                </a:solidFill>
+              </a:defRPr>
+            </a:pPr>
+            <a:r>
+              <a:t>• Synthesized voice dispatch readouts announcing tactical shift orders to field units.</a:t>
+            </a:r>
+          </a:p>
+          <a:p>
+            <a:pPr>
+              <a:defRPr sz="1000">
+                <a:solidFill>
+                  <a:srgbClr val="CBD5E1"/>
+                </a:solidFill>
+              </a:defRPr>
+            </a:pPr>
+            <a:r>
+              <a:t>• Web Audio API dual-frequency tactical chimes and urgent warning siren tones.</a:t>
             </a:r>
           </a:p>
         </p:txBody>
@@ -4369,14 +4637,14 @@
         </p:nvSpPr>
         <p:spPr>
           <a:xfrm>
-            <a:off x="6217920" y="4114800"/>
+            <a:off x="6217920" y="4023360"/>
             <a:ext cx="5212080" cy="2331720"/>
           </a:xfrm>
           <a:prstGeom prst="roundRect">
             <a:avLst/>
           </a:prstGeom>
           <a:solidFill>
-            <a:srgbClr val="111827"/>
+            <a:srgbClr val="0F172A"/>
           </a:solidFill>
           <a:ln>
             <a:solidFill>
@@ -4410,31 +4678,56 @@
               </a:defRPr>
             </a:pPr>
             <a:r>
-              <a:t>STANDARDS COMPLIANCE</a:t>
-            </a:r>
-          </a:p>
-          <a:p>
-            <a:pPr>
-              <a:defRPr sz="1500" b="1">
+              <a:t>STANDARDS &amp; CHAOS ENGINEERING</a:t>
+            </a:r>
+          </a:p>
+          <a:p>
+            <a:pPr>
+              <a:defRPr sz="1400" b="1">
                 <a:solidFill>
                   <a:srgbClr val="F8FAFC"/>
                 </a:solidFill>
               </a:defRPr>
             </a:pPr>
             <a:r>
-              <a:t>Multi-Hazard Simulator &amp; FEMA ICS-201</a:t>
-            </a:r>
-          </a:p>
-          <a:p>
-            <a:pPr>
-              <a:defRPr sz="1100">
+              <a:t>Multi-Hazard Chaos Engine &amp; FEMA ICS-201</a:t>
+            </a:r>
+          </a:p>
+          <a:p/>
+          <a:p>
+            <a:pPr>
+              <a:defRPr sz="1000">
                 <a:solidFill>
                   <a:srgbClr val="CBD5E1"/>
                 </a:solidFill>
               </a:defRPr>
             </a:pPr>
             <a:r>
-              <a:t>Live crisis drawer injects 7.1 Earthquakes, Flash Floods, Wildfires, Blackouts, and Chemical Blasts. Auto-generates full FEMA ICS-201 Incident Action Plans ready for instant Print/PDF and Markdown download.</a:t>
+              <a:t>• Disaster injection drawer: 7.1 Earthquake, Flash Flood, Wildfire, Grid Blackout, Chemical Blast.</a:t>
+            </a:r>
+          </a:p>
+          <a:p>
+            <a:pPr>
+              <a:defRPr sz="1000">
+                <a:solidFill>
+                  <a:srgbClr val="CBD5E1"/>
+                </a:solidFill>
+              </a:defRPr>
+            </a:pPr>
+            <a:r>
+              <a:t>• Department Commander consoles (Fire, Medical, Rescue, Police) with unit status toggling.</a:t>
+            </a:r>
+          </a:p>
+          <a:p>
+            <a:pPr>
+              <a:defRPr sz="1000">
+                <a:solidFill>
+                  <a:srgbClr val="CBD5E1"/>
+                </a:solidFill>
+              </a:defRPr>
+            </a:pPr>
+            <a:r>
+              <a:t>• Instant FEMA Form ICS-201 Incident Action Plan generator with 1-click Print/PDF &amp; Markdown export.</a:t>
             </a:r>
           </a:p>
         </p:txBody>
@@ -4473,8 +4766,8 @@
         </p:nvSpPr>
         <p:spPr>
           <a:xfrm>
-            <a:off x="731520" y="365760"/>
-            <a:ext cx="10698480" cy="320040"/>
+            <a:off x="731520" y="320040"/>
+            <a:ext cx="10698480" cy="274320"/>
           </a:xfrm>
           <a:prstGeom prst="rect">
             <a:avLst/>
@@ -4495,7 +4788,7 @@
               </a:defRPr>
             </a:pPr>
             <a:r>
-              <a:t>VALUE CREATION // PRODUCTION READY</a:t>
+              <a:t>EXECUTION &amp; RESILIENCE // FIELD READINESS</a:t>
             </a:r>
           </a:p>
         </p:txBody>
@@ -4508,8 +4801,8 @@
         </p:nvSpPr>
         <p:spPr>
           <a:xfrm>
-            <a:off x="731520" y="640080"/>
-            <a:ext cx="10698480" cy="640080"/>
+            <a:off x="731520" y="594360"/>
+            <a:ext cx="10698480" cy="548640"/>
           </a:xfrm>
           <a:prstGeom prst="rect">
             <a:avLst/>
@@ -4523,14 +4816,14 @@
           <a:lstStyle/>
           <a:p>
             <a:pPr>
-              <a:defRPr sz="2400" b="1">
+              <a:defRPr sz="2200" b="1">
                 <a:solidFill>
                   <a:srgbClr val="F8FAFC"/>
                 </a:solidFill>
               </a:defRPr>
             </a:pPr>
             <a:r>
-              <a:t>Operational Impact, Verification &amp; Technology Stack</a:t>
+              <a:t>Engineering Challenges Overcome &amp; Production Impact</a:t>
             </a:r>
           </a:p>
         </p:txBody>
@@ -4543,8 +4836,8 @@
         </p:nvSpPr>
         <p:spPr>
           <a:xfrm>
-            <a:off x="731520" y="1280160"/>
-            <a:ext cx="10698480" cy="18288"/>
+            <a:off x="731520" y="1188720"/>
+            <a:ext cx="10728655" cy="18288"/>
           </a:xfrm>
           <a:prstGeom prst="rect">
             <a:avLst/>
@@ -4588,14 +4881,167 @@
         </p:nvSpPr>
         <p:spPr>
           <a:xfrm>
-            <a:off x="731520" y="1554480"/>
-            <a:ext cx="4114800" cy="4846320"/>
+            <a:off x="731520" y="1463040"/>
+            <a:ext cx="5669280" cy="4937760"/>
           </a:xfrm>
           <a:prstGeom prst="roundRect">
             <a:avLst/>
           </a:prstGeom>
           <a:solidFill>
-            <a:srgbClr val="111827"/>
+            <a:srgbClr val="0F172A"/>
+          </a:solidFill>
+          <a:ln>
+            <a:solidFill>
+              <a:srgbClr val="F59E0B"/>
+            </a:solidFill>
+          </a:ln>
+        </p:spPr>
+        <p:style>
+          <a:lnRef idx="1">
+            <a:schemeClr val="accent1"/>
+          </a:lnRef>
+          <a:fillRef idx="3">
+            <a:schemeClr val="accent1"/>
+          </a:fillRef>
+          <a:effectRef idx="2">
+            <a:schemeClr val="accent1"/>
+          </a:effectRef>
+          <a:fontRef idx="minor">
+            <a:schemeClr val="lt1"/>
+          </a:fontRef>
+        </p:style>
+        <p:txBody>
+          <a:bodyPr rtlCol="0" anchor="ctr" wrap="square" lIns="228600" rIns="228600" tIns="182880"/>
+          <a:lstStyle/>
+          <a:p>
+            <a:pPr algn="ctr">
+              <a:defRPr sz="1000" b="1">
+                <a:solidFill>
+                  <a:srgbClr val="F59E0B"/>
+                </a:solidFill>
+              </a:defRPr>
+            </a:pPr>
+            <a:r>
+              <a:t>KEY CHALLENGES OVERCOME</a:t>
+            </a:r>
+          </a:p>
+          <a:p>
+            <a:pPr>
+              <a:defRPr sz="1600" b="1">
+                <a:solidFill>
+                  <a:srgbClr val="F8FAFC"/>
+                </a:solidFill>
+              </a:defRPr>
+            </a:pPr>
+            <a:r>
+              <a:t>Technical Roadblocks &amp; Engineering Fixes</a:t>
+            </a:r>
+          </a:p>
+          <a:p/>
+          <a:p>
+            <a:pPr>
+              <a:defRPr sz="1200" b="1">
+                <a:solidFill>
+                  <a:srgbClr val="FBBF24"/>
+                </a:solidFill>
+              </a:defRPr>
+            </a:pPr>
+            <a:r>
+              <a:t>1. LLM Hallucinations in Life-Safety Allocation</a:t>
+            </a:r>
+          </a:p>
+          <a:p>
+            <a:pPr>
+              <a:defRPr sz="950">
+                <a:solidFill>
+                  <a:srgbClr val="CBD5E1"/>
+                </a:solidFill>
+              </a:defRPr>
+            </a:pPr>
+            <a:r>
+              <a:t>Problem: Pure generative LLMs produced unpredictable, non-deterministic apparatus routing.</a:t>
+            </a:r>
+            <a:br/>
+            <a:r>
+              <a:t>Solution: Engineered a hybrid architecture: LangGraph models the decision workflow, but all resource allocations execute through a deterministic multi-factor mathematical scoring engine.</a:t>
+            </a:r>
+          </a:p>
+          <a:p/>
+          <a:p>
+            <a:pPr>
+              <a:defRPr sz="1200" b="1">
+                <a:solidFill>
+                  <a:srgbClr val="FBBF24"/>
+                </a:solidFill>
+              </a:defRPr>
+            </a:pPr>
+            <a:r>
+              <a:t>2. Real-Time State Lag &amp; Approval Banner Stalling</a:t>
+            </a:r>
+          </a:p>
+          <a:p>
+            <a:pPr>
+              <a:defRPr sz="950">
+                <a:solidFill>
+                  <a:srgbClr val="CBD5E1"/>
+                </a:solidFill>
+              </a:defRPr>
+            </a:pPr>
+            <a:r>
+              <a:t>Problem: React state re-renders and polling caused the Replanning Banner to linger even after user approval.</a:t>
+            </a:r>
+            <a:br/>
+            <a:r>
+              <a:t>Solution: Added optimistic instant local state dismissal ('isDismissed = true') synchronized with atomic backend cache purging and smart event-tracking ('lastSeenEventId').</a:t>
+            </a:r>
+          </a:p>
+          <a:p/>
+          <a:p>
+            <a:pPr>
+              <a:defRPr sz="1200" b="1">
+                <a:solidFill>
+                  <a:srgbClr val="FBBF24"/>
+                </a:solidFill>
+              </a:defRPr>
+            </a:pPr>
+            <a:r>
+              <a:t>3. GIS Tile Restrictions &amp; Cross-Origin (CORS) Blocks</a:t>
+            </a:r>
+          </a:p>
+          <a:p>
+            <a:pPr>
+              <a:defRPr sz="950">
+                <a:solidFill>
+                  <a:srgbClr val="CBD5E1"/>
+                </a:solidFill>
+              </a:defRPr>
+            </a:pPr>
+            <a:r>
+              <a:t>Problem: CartoDB basemaps added 'API KEY REQUIRED' watermarks; Vercel &amp; Render had CORS preflights.</a:t>
+            </a:r>
+            <a:br/>
+            <a:r>
+              <a:t>Solution: Migrated to zero-key Esri World Dark Gray &amp; OpenStreetMap tiles; added permissive regex-based CORS middleware allowing multi-cloud deployments seamlessly.</a:t>
+            </a:r>
+          </a:p>
+        </p:txBody>
+      </p:sp>
+      <p:sp>
+        <p:nvSpPr>
+          <p:cNvPr id="6" name="Rounded Rectangle 5"/>
+          <p:cNvSpPr/>
+          <p:nvPr/>
+        </p:nvSpPr>
+        <p:spPr>
+          <a:xfrm>
+            <a:off x="6675120" y="1463040"/>
+            <a:ext cx="4754880" cy="4937760"/>
+          </a:xfrm>
+          <a:prstGeom prst="roundRect">
+            <a:avLst/>
+          </a:prstGeom>
+          <a:solidFill>
+            <a:srgbClr val="0F172A"/>
           </a:solidFill>
           <a:ln>
             <a:solidFill>
@@ -4618,7 +5064,7 @@
           </a:fontRef>
         </p:style>
         <p:txBody>
-          <a:bodyPr rtlCol="0" anchor="ctr" wrap="square" lIns="274320" rIns="274320" tIns="274320"/>
+          <a:bodyPr rtlCol="0" anchor="ctr" wrap="square" lIns="228600" rIns="228600" tIns="182880"/>
           <a:lstStyle/>
           <a:p>
             <a:pPr algn="ctr">
@@ -4629,310 +5075,119 @@
               </a:defRPr>
             </a:pPr>
             <a:r>
-              <a:t>PROVEN OPERATIONAL METRICS</a:t>
-            </a:r>
-          </a:p>
-          <a:p>
-            <a:pPr>
-              <a:defRPr sz="1800" b="1">
+              <a:t>VERIFIED IMPACT &amp; TECH STACK</a:t>
+            </a:r>
+          </a:p>
+          <a:p>
+            <a:pPr>
+              <a:defRPr sz="1600" b="1">
                 <a:solidFill>
                   <a:srgbClr val="F8FAFC"/>
                 </a:solidFill>
               </a:defRPr>
             </a:pPr>
             <a:r>
-              <a:t>Demonstrated Impact</a:t>
+              <a:t>Field Readiness &amp; Architecture</a:t>
             </a:r>
           </a:p>
           <a:p/>
           <a:p>
             <a:pPr>
-              <a:defRPr sz="1400" b="1">
-                <a:solidFill>
-                  <a:srgbClr val="10B981"/>
-                </a:solidFill>
-              </a:defRPr>
-            </a:pPr>
-            <a:r>
-              <a:t>~85% Faster Dispatch</a:t>
-            </a:r>
-          </a:p>
-          <a:p>
-            <a:pPr>
-              <a:defRPr sz="1100">
+              <a:defRPr sz="1200" b="1">
+                <a:solidFill>
+                  <a:srgbClr val="34D399"/>
+                </a:solidFill>
+              </a:defRPr>
+            </a:pPr>
+            <a:r>
+              <a:t>⚡ ~85% Latency Reduction</a:t>
+            </a:r>
+          </a:p>
+          <a:p>
+            <a:pPr>
+              <a:defRPr sz="950">
                 <a:solidFill>
                   <a:srgbClr val="CBD5E1"/>
                 </a:solidFill>
               </a:defRPr>
             </a:pPr>
             <a:r>
-              <a:t>Reduces inter-agency triage and coordination latency from 15+ minutes to milliseconds.</a:t>
+              <a:t>Cross-agency allocation completes in under 200ms vs 15+ minutes of manual radio dispatching.</a:t>
             </a:r>
           </a:p>
           <a:p/>
           <a:p>
             <a:pPr>
-              <a:defRPr sz="1400" b="1">
-                <a:solidFill>
-                  <a:srgbClr val="10B981"/>
-                </a:solidFill>
-              </a:defRPr>
-            </a:pPr>
-            <a:r>
-              <a:t>100% Explainability</a:t>
-            </a:r>
-          </a:p>
-          <a:p>
-            <a:pPr>
-              <a:defRPr sz="1100">
+              <a:defRPr sz="1200" b="1">
+                <a:solidFill>
+                  <a:srgbClr val="34D399"/>
+                </a:solidFill>
+              </a:defRPr>
+            </a:pPr>
+            <a:r>
+              <a:t>🛡️ 100% Explainable Audits</a:t>
+            </a:r>
+          </a:p>
+          <a:p>
+            <a:pPr>
+              <a:defRPr sz="950">
                 <a:solidFill>
                   <a:srgbClr val="CBD5E1"/>
                 </a:solidFill>
               </a:defRPr>
             </a:pPr>
             <a:r>
-              <a:t>Deterministic algorithmic rationale for every unit reallocated—eliminating hallucination risks.</a:t>
+              <a:t>Every preemption logs explicit 'Before vs After' and causal reasons for transparency.</a:t>
             </a:r>
           </a:p>
           <a:p/>
           <a:p>
             <a:pPr>
-              <a:defRPr sz="1400" b="1">
-                <a:solidFill>
-                  <a:srgbClr val="10B981"/>
-                </a:solidFill>
-              </a:defRPr>
-            </a:pPr>
-            <a:r>
-              <a:t>Zero Downtime Replanning</a:t>
-            </a:r>
-          </a:p>
-          <a:p>
-            <a:pPr>
-              <a:defRPr sz="1100">
+              <a:defRPr sz="1200" b="1">
+                <a:solidFill>
+                  <a:srgbClr val="34D399"/>
+                </a:solidFill>
+              </a:defRPr>
+            </a:pPr>
+            <a:r>
+              <a:t>🌐 Multi-Cloud Production Ready</a:t>
+            </a:r>
+          </a:p>
+          <a:p>
+            <a:pPr>
+              <a:defRPr sz="950">
                 <a:solidFill>
                   <a:srgbClr val="CBD5E1"/>
                 </a:solidFill>
               </a:defRPr>
             </a:pPr>
             <a:r>
-              <a:t>Instant state re-evaluation on apparatus failure or secondary disaster shock waves.</a:t>
+              <a:t>Live on Vercel (Frontend), Dockerized single-container FastAPI (Backend), zero-downtime test suite.</a:t>
             </a:r>
           </a:p>
           <a:p/>
           <a:p>
             <a:pPr>
-              <a:defRPr sz="1400" b="1">
-                <a:solidFill>
-                  <a:srgbClr val="10B981"/>
-                </a:solidFill>
-              </a:defRPr>
-            </a:pPr>
-            <a:r>
-              <a:t>FEMA Standard Aligned</a:t>
-            </a:r>
-          </a:p>
-          <a:p>
-            <a:pPr>
-              <a:defRPr sz="1100">
+              <a:defRPr sz="1200" b="1">
+                <a:solidFill>
+                  <a:srgbClr val="34D399"/>
+                </a:solidFill>
+              </a:defRPr>
+            </a:pPr>
+            <a:r>
+              <a:t>💻 Technology Stack</a:t>
+            </a:r>
+          </a:p>
+          <a:p>
+            <a:pPr>
+              <a:defRPr sz="950">
                 <a:solidFill>
                   <a:srgbClr val="CBD5E1"/>
                 </a:solidFill>
               </a:defRPr>
             </a:pPr>
             <a:r>
-              <a:t>Adheres to National Incident Management System (NIMS) ICS-201 command briefs.</a:t>
-            </a:r>
-          </a:p>
-        </p:txBody>
-      </p:sp>
-      <p:sp>
-        <p:nvSpPr>
-          <p:cNvPr id="6" name="Rounded Rectangle 5"/>
-          <p:cNvSpPr/>
-          <p:nvPr/>
-        </p:nvSpPr>
-        <p:spPr>
-          <a:xfrm>
-            <a:off x="5120640" y="1554480"/>
-            <a:ext cx="6309360" cy="4846320"/>
-          </a:xfrm>
-          <a:prstGeom prst="roundRect">
-            <a:avLst/>
-          </a:prstGeom>
-          <a:solidFill>
-            <a:srgbClr val="111827"/>
-          </a:solidFill>
-          <a:ln>
-            <a:solidFill>
-              <a:srgbClr val="0EA5E9"/>
-            </a:solidFill>
-          </a:ln>
-        </p:spPr>
-        <p:style>
-          <a:lnRef idx="1">
-            <a:schemeClr val="accent1"/>
-          </a:lnRef>
-          <a:fillRef idx="3">
-            <a:schemeClr val="accent1"/>
-          </a:fillRef>
-          <a:effectRef idx="2">
-            <a:schemeClr val="accent1"/>
-          </a:effectRef>
-          <a:fontRef idx="minor">
-            <a:schemeClr val="lt1"/>
-          </a:fontRef>
-        </p:style>
-        <p:txBody>
-          <a:bodyPr rtlCol="0" anchor="ctr" wrap="square" lIns="274320" rIns="274320" tIns="274320"/>
-          <a:lstStyle/>
-          <a:p>
-            <a:pPr algn="ctr">
-              <a:defRPr sz="1000" b="1">
-                <a:solidFill>
-                  <a:srgbClr val="0EA5E9"/>
-                </a:solidFill>
-              </a:defRPr>
-            </a:pPr>
-            <a:r>
-              <a:t>FULL-STACK PRODUCTION ARCHITECTURE</a:t>
-            </a:r>
-          </a:p>
-          <a:p>
-            <a:pPr>
-              <a:defRPr sz="1800" b="1">
-                <a:solidFill>
-                  <a:srgbClr val="F8FAFC"/>
-                </a:solidFill>
-              </a:defRPr>
-            </a:pPr>
-            <a:r>
-              <a:t>Engineered for Resilient Deployment</a:t>
-            </a:r>
-          </a:p>
-          <a:p/>
-          <a:p>
-            <a:pPr>
-              <a:defRPr sz="1300" b="1">
-                <a:solidFill>
-                  <a:srgbClr val="38BDF8"/>
-                </a:solidFill>
-              </a:defRPr>
-            </a:pPr>
-            <a:r>
-              <a:t>AI &amp; Decision Core</a:t>
-            </a:r>
-          </a:p>
-          <a:p>
-            <a:pPr>
-              <a:defRPr sz="1100">
-                <a:solidFill>
-                  <a:srgbClr val="CBD5E1"/>
-                </a:solidFill>
-              </a:defRPr>
-            </a:pPr>
-            <a:r>
-              <a:t>LangGraph StateGraph, LangChain, Pydantic v2, Python 3.11, Deterministic Multi-Factor Math Engine.</a:t>
-            </a:r>
-          </a:p>
-          <a:p/>
-          <a:p>
-            <a:pPr>
-              <a:defRPr sz="1300" b="1">
-                <a:solidFill>
-                  <a:srgbClr val="38BDF8"/>
-                </a:solidFill>
-              </a:defRPr>
-            </a:pPr>
-            <a:r>
-              <a:t>Backend &amp; Services</a:t>
-            </a:r>
-          </a:p>
-          <a:p>
-            <a:pPr>
-              <a:defRPr sz="1100">
-                <a:solidFill>
-                  <a:srgbClr val="CBD5E1"/>
-                </a:solidFill>
-              </a:defRPr>
-            </a:pPr>
-            <a:r>
-              <a:t>FastAPI (Asynchronous REST API, SSE streaming ready), Uvicorn, Automated Pytest validation suite.</a:t>
-            </a:r>
-          </a:p>
-          <a:p/>
-          <a:p>
-            <a:pPr>
-              <a:defRPr sz="1300" b="1">
-                <a:solidFill>
-                  <a:srgbClr val="38BDF8"/>
-                </a:solidFill>
-              </a:defRPr>
-            </a:pPr>
-            <a:r>
-              <a:t>Frontend UI &amp; GIS</a:t>
-            </a:r>
-          </a:p>
-          <a:p>
-            <a:pPr>
-              <a:defRPr sz="1100">
-                <a:solidFill>
-                  <a:srgbClr val="CBD5E1"/>
-                </a:solidFill>
-              </a:defRPr>
-            </a:pPr>
-            <a:r>
-              <a:t>React 19, TypeScript, Tailwind CSS v4, Lucide Icons, Leaflet GIS with Esri Dark Canvas tiles.</a:t>
-            </a:r>
-          </a:p>
-          <a:p/>
-          <a:p>
-            <a:pPr>
-              <a:defRPr sz="1300" b="1">
-                <a:solidFill>
-                  <a:srgbClr val="38BDF8"/>
-                </a:solidFill>
-              </a:defRPr>
-            </a:pPr>
-            <a:r>
-              <a:t>3D Graphics &amp; Audio</a:t>
-            </a:r>
-          </a:p>
-          <a:p>
-            <a:pPr>
-              <a:defRPr sz="1100">
-                <a:solidFill>
-                  <a:srgbClr val="CBD5E1"/>
-                </a:solidFill>
-              </a:defRPr>
-            </a:pPr>
-            <a:r>
-              <a:t>Three.js WebGL (Interactive Particle Globe &amp; Camera Warp), Web Audio API, SpeechSynthesis dispatch.</a:t>
-            </a:r>
-          </a:p>
-          <a:p/>
-          <a:p>
-            <a:pPr>
-              <a:defRPr sz="1300" b="1">
-                <a:solidFill>
-                  <a:srgbClr val="38BDF8"/>
-                </a:solidFill>
-              </a:defRPr>
-            </a:pPr>
-            <a:r>
-              <a:t>DevOps &amp; Deployment</a:t>
-            </a:r>
-          </a:p>
-          <a:p>
-            <a:pPr>
-              <a:defRPr sz="1100">
-                <a:solidFill>
-                  <a:srgbClr val="CBD5E1"/>
-                </a:solidFill>
-              </a:defRPr>
-            </a:pPr>
-            <a:r>
-              <a:t>Docker multi-stage build, Unified single-container SPA hosting, Vercel &amp; Render production pipelines.</a:t>
+              <a:t>LangGraph, Python 3.11, FastAPI, React 19, TypeScript, Tailwind CSS v4, Three.js WebGL, Leaflet GIS, Docker.</a:t>
             </a:r>
           </a:p>
         </p:txBody>

</xml_diff>